<commit_message>
fix: definition of darak matter
</commit_message>
<xml_diff>
--- a/2606/training_set_report.pptx
+++ b/2606/training_set_report.pptx
@@ -11373,7 +11373,7 @@
                             <a:srgbClr val="A93226"/>
                           </a:solidFill>
                         </a:rPr>
-                        <a:t>Background min = 0.2 for all positives</a:t>
+                        <a:t>Protein-altering threshold = 0.6 (SO:0001818)</a:t>
                       </a:r>
                       <a:endParaRPr lang="en-US" sz="1000" dirty="0"/>
                     </a:p>
@@ -11896,7 +11896,7 @@
                   <a:srgbClr val="06B6D4"/>
                 </a:solidFill>
               </a:rPr>
-              <a:t>Definition: </a:t>
+              <a:t xml:space="preserve">Definition: </a:t>
             </a:r>
             <a:r>
               <a:rPr lang="en-US" sz="1150" dirty="0">
@@ -11904,7 +11904,7 @@
                   <a:srgbClr val="CBD5E1"/>
                 </a:solidFill>
               </a:rPr>
-              <a:t>GSP=1 rows that are (1) not nearest by TSS, (2) not nearest by footprint, AND (3) have zero value across all QTL colocalisation and E2G features. The only remaining signal is distance rank and background VEP (min 0.2 for all positives — not gene-specific).</a:t>
+              <a:t>GSP=1 rows where (1) all four neighbourhood distances &lt; 1.0 (not nearest by TSS, footprint, mean-TSS, or mean-footprint), AND (2) all QTL colocalisation and E2G features are zero, AND (3) vepMaximum &lt; 0.6 (below protein-altering variant threshold, SO:0001818). Nearest-gene positives (any neighbourhood = 1.0) are always kept.</a:t>
             </a:r>
             <a:endParaRPr lang="en-US" sz="1150" dirty="0"/>
           </a:p>
@@ -11972,7 +11972,7 @@
                   <a:srgbClr val="E74C3C"/>
                 </a:solidFill>
               </a:rPr>
-              <a:t>22.8%</a:t>
+              <a:t>22.4%</a:t>
             </a:r>
             <a:endParaRPr lang="en-US" sz="3400" dirty="0"/>
           </a:p>
@@ -12008,7 +12008,7 @@
                   <a:srgbClr val="FFFFFF"/>
                 </a:solidFill>
               </a:rPr>
-              <a:t>2,977</a:t>
+              <a:t>2,928</a:t>
             </a:r>
             <a:endParaRPr lang="en-US" sz="1600" dirty="0"/>
           </a:p>
@@ -12148,7 +12148,7 @@
                   <a:srgbClr val="E74C3C"/>
                 </a:solidFill>
               </a:rPr>
-              <a:t>22.5%</a:t>
+              <a:t>0.0%</a:t>
             </a:r>
             <a:endParaRPr lang="en-US" sz="3400" dirty="0"/>
           </a:p>
@@ -12184,7 +12184,7 @@
                   <a:srgbClr val="FFFFFF"/>
                 </a:solidFill>
               </a:rPr>
-              <a:t>1,621</a:t>
+              <a:t>0</a:t>
             </a:r>
             <a:endParaRPr lang="en-US" sz="1600" dirty="0"/>
           </a:p>
@@ -12324,7 +12324,7 @@
                   <a:srgbClr val="E74C3C"/>
                 </a:solidFill>
               </a:rPr>
-              <a:t>56.8%</a:t>
+              <a:t>50.0%</a:t>
             </a:r>
             <a:endParaRPr lang="en-US" sz="3400" dirty="0"/>
           </a:p>
@@ -12360,7 +12360,7 @@
                   <a:srgbClr val="FFFFFF"/>
                 </a:solidFill>
               </a:rPr>
-              <a:t>3,325</a:t>
+              <a:t>2,928</a:t>
             </a:r>
             <a:endParaRPr lang="en-US" sz="1600" dirty="0"/>
           </a:p>
@@ -12536,7 +12536,7 @@
                   <a:srgbClr val="CBD5E1"/>
                 </a:solidFill>
               </a:rPr>
-              <a:t>Dark matter positives have feature vectors identical to thousands of negatives (QTL=0, E2G=0, non-nearest). The model receives conflicting gradient signal — identical inputs labelled both 0 and 1 — degrading decision boundaries for the 77.2% of positives that are learnable.</a:t>
+              <a:t>Dark matter positives have feature vectors identical to thousands of negatives (QTL=0, E2G=0, VEP&lt;0.6, non-nearest). The model receives conflicting gradient signal — identical inputs labelled both 0 and 1 — degrading decision boundaries for the 77.6% of positives that are learnable.</a:t>
             </a:r>
             <a:endParaRPr lang="en-US" sz="1050" dirty="0"/>
           </a:p>
@@ -12640,7 +12640,7 @@
                   <a:srgbClr val="CBD5E1"/>
                 </a:solidFill>
               </a:rPr>
-              <a:t>Remove dark matter loci from training (all rows for those 2,933 studyLocusIds).
+              <a:t>Remove loci where ALL positives are dark matter (2,639 studyLocusIds). Loci with mixed signal are kept in full.
 </a:t>
             </a:r>
             <a:r>
@@ -12649,7 +12649,7 @@
                   <a:srgbClr val="06B6D4"/>
                 </a:solidFill>
               </a:rPr>
-              <a:t>Effect: </a:t>
+              <a:t xml:space="preserve">Effect: </a:t>
             </a:r>
             <a:r>
               <a:rPr lang="en-US" sz="1050" dirty="0">
@@ -12657,7 +12657,7 @@
                   <a:srgbClr val="CBD5E1"/>
                 </a:solidFill>
               </a:rPr>
-              <a:t>146,626 rows remain. Nearest-TSS proportion 55.1% → 71.7%. Non-nearest fold-change over negatives roughly doubles. At inference on full FM, dark-matter-type loci default to nearest-gene prediction — the only valid fallback when no functional evidence exists.</a:t>
+              <a:t>152,687 rows remain (−23.9%). Nearest-TSS proportion 55.1% → 69.4% (+14.3 pp). Non-nearest fold-change over negatives roughly doubles. 245 residual dark matter positives in mixed loci are retained by design.</a:t>
             </a:r>
             <a:endParaRPr lang="en-US" sz="1050" dirty="0"/>
           </a:p>

</xml_diff>